<commit_message>
Add slide clarifying weapon, non-weapon and OOD roles
</commit_message>
<xml_diff>
--- a/Molinario_Thesis_Defense_2026.pptx
+++ b/Molinario_Thesis_Defense_2026.pptx
@@ -12,6 +12,7 @@
     <p:sldId id="257" r:id="rId3"/>
     <p:sldId id="258" r:id="rId4"/>
     <p:sldId id="259" r:id="rId5"/>
+    <p:sldId id="284" r:id="rId33"/>
     <p:sldId id="260" r:id="rId6"/>
     <p:sldId id="261" r:id="rId7"/>
     <p:sldId id="262" r:id="rId8"/>
@@ -3048,6 +3049,81 @@
 </p:notes>
 </file>
 
+<file path=ppt/notesSlides/notesSlide24.xml><?xml version="1.0" encoding="utf-8"?>
+<p:notes xmlns:a="http://schemas.openxmlformats.org/drawingml/2006/main" xmlns:p="http://schemas.openxmlformats.org/presentationml/2006/main" xmlns:r="http://schemas.openxmlformats.org/officeDocument/2006/relationships">
+  <p:cSld>
+    <p:spTree>
+      <p:nvGrpSpPr>
+        <p:cNvPr id="1" name=""/>
+        <p:cNvGrpSpPr/>
+        <p:nvPr/>
+      </p:nvGrpSpPr>
+      <p:grpSpPr>
+        <a:xfrm>
+          <a:off x="0" y="0"/>
+          <a:ext cx="0" cy="0"/>
+          <a:chOff x="0" y="0"/>
+          <a:chExt cx="0" cy="0"/>
+        </a:xfrm>
+      </p:grpSpPr>
+      <p:sp>
+        <p:nvSpPr>
+          <p:cNvPr id="2" name="Slide Image Placeholder 1"/>
+          <p:cNvSpPr>
+            <a:spLocks noGrp="1"/>
+          </p:cNvSpPr>
+          <p:nvPr>
+            <p:ph type="sldImg" idx="2"/>
+          </p:nvPr>
+        </p:nvSpPr>
+        <p:spPr/>
+      </p:sp>
+      <p:sp>
+        <p:nvSpPr>
+          <p:cNvPr id="3" name="Notes Placeholder 2"/>
+          <p:cNvSpPr>
+            <a:spLocks noGrp="1"/>
+          </p:cNvSpPr>
+          <p:nvPr>
+            <p:ph type="body" idx="3" sz="quarter"/>
+          </p:nvPr>
+        </p:nvSpPr>
+        <p:spPr/>
+        <p:txBody>
+          <a:bodyPr/>
+          <a:lstStyle/>
+          <a:p>
+            <a:r>
+              <a:t>The binary task contains two in-distribution groups: weapon and non-weapon. Weapon images contain a real firearm or firearm-like object sufficiently visible and relevant to the triage task. Non-weapon images are realistic negatives with no firearm but remain compatible with the same visual domain. OOD is different: it is a separate robustness branch containing borderline, synthetic, degraded, ambiguous or semantically external inputs, such as toys or replicas, CGI, non-firearm weapons or war imagery. OOD is not a third supervised class; it is used to observe closed-set behavior outside the intended binary distribution.</a:t>
+            </a:r>
+          </a:p>
+          <a:p>
+            <a:r>
+              <a:t>Transition: With this distinction clear, I can now explain the two evidence levels used in the evaluation.</a:t>
+            </a:r>
+          </a:p>
+        </p:txBody>
+      </p:sp>
+      <p:sp>
+        <p:nvSpPr>
+          <p:cNvPr id="4" name="Slide Number Placeholder 3"/>
+          <p:cNvSpPr>
+            <a:spLocks noGrp="1"/>
+          </p:cNvSpPr>
+          <p:nvPr>
+            <p:ph type="sldNum" idx="5" sz="quarter"/>
+          </p:nvPr>
+        </p:nvSpPr>
+        <p:spPr/>
+      </p:sp>
+    </p:spTree>
+  </p:cSld>
+  <p:clrMapOvr>
+    <a:masterClrMapping/>
+  </p:clrMapOvr>
+</p:notes>
+</file>
+
 <file path=ppt/notesSlides/notesSlide3.xml><?xml version="1.0" encoding="utf-8"?>
 <p:notes xmlns:a="http://schemas.openxmlformats.org/drawingml/2006/main" xmlns:r="http://schemas.openxmlformats.org/officeDocument/2006/relationships" xmlns:p="http://schemas.openxmlformats.org/presentationml/2006/main">
   <p:cSld>
@@ -3185,22 +3261,12 @@
           <a:lstStyle/>
           <a:p>
             <a:r>
-              <a:rPr lang="it-IT" dirty="0"/>
-              <a:t>T</a:t>
-            </a:r>
-            <a:r>
-              <a:rPr dirty="0"/>
-              <a:t>he frozen population contains 1,500 source images: 500 weapon, 500 non-weapon and 500 images in a separate OOD branch. The 1,000 binary images produce ten linked variants each, for 10,000 adversarial and anti-forensic files. Together with the clean sources, the tool-facing bundle contains 11,500 files. The variants remain linked to their sources; they are not 10,000 independent cases. OOD is evaluated separately, not as a third supervised class.</a:t>
-            </a:r>
-          </a:p>
-          <a:p>
-            <a:r>
-              <a:rPr b="1" dirty="0"/>
-              <a:t>Transition</a:t>
-            </a:r>
-            <a:r>
-              <a:rPr dirty="0"/>
-              <a:t>: I used this same frozen population at two evidence levels.</a:t>
+              <a:t>The frozen population contains 1,500 source images: 500 weapon, 500 non-weapon and 500 images in a separate OOD branch. The 1,000 binary images produce ten linked variants each, for 10,000 adversarial and anti-forensic files. Together with the clean sources, the tool-facing bundle contains 11,500 files. The variants remain linked to their sources; they are not 10,000 independent cases. OOD is evaluated separately, not as a third supervised class.</a:t>
+            </a:r>
+          </a:p>
+          <a:p>
+            <a:r>
+              <a:t>Transition: Before moving to the tools, I will clarify how weapon, non-weapon and OOD play different roles.</a:t>
             </a:r>
           </a:p>
         </p:txBody>
@@ -8154,8 +8220,15 @@
           </a:bodyPr>
           <a:lstStyle/>
           <a:p>
-            <a:r>
-              <a:t>10</a:t>
+            <a:pPr algn="ctr"/>
+            <a:r>
+              <a:rPr sz="1500">
+                <a:solidFill>
+                  <a:srgbClr val="182235"/>
+                </a:solidFill>
+                <a:latin typeface="Arial"/>
+              </a:rPr>
+              <a:t>11</a:t>
             </a:r>
           </a:p>
         </p:txBody>
@@ -8876,8 +8949,15 @@
           </a:bodyPr>
           <a:lstStyle/>
           <a:p>
-            <a:r>
-              <a:t>11</a:t>
+            <a:pPr algn="ctr"/>
+            <a:r>
+              <a:rPr sz="1500">
+                <a:solidFill>
+                  <a:srgbClr val="182235"/>
+                </a:solidFill>
+                <a:latin typeface="Arial"/>
+              </a:rPr>
+              <a:t>12</a:t>
             </a:r>
           </a:p>
         </p:txBody>
@@ -10191,8 +10271,15 @@
           </a:bodyPr>
           <a:lstStyle/>
           <a:p>
-            <a:r>
-              <a:t>12</a:t>
+            <a:pPr algn="ctr"/>
+            <a:r>
+              <a:rPr sz="1500">
+                <a:solidFill>
+                  <a:srgbClr val="182235"/>
+                </a:solidFill>
+                <a:latin typeface="Arial"/>
+              </a:rPr>
+              <a:t>13</a:t>
             </a:r>
           </a:p>
         </p:txBody>
@@ -11981,8 +12068,15 @@
           </a:bodyPr>
           <a:lstStyle/>
           <a:p>
-            <a:r>
-              <a:t>13</a:t>
+            <a:pPr algn="ctr"/>
+            <a:r>
+              <a:rPr sz="1500">
+                <a:solidFill>
+                  <a:srgbClr val="182235"/>
+                </a:solidFill>
+                <a:latin typeface="Arial"/>
+              </a:rPr>
+              <a:t>14</a:t>
             </a:r>
           </a:p>
         </p:txBody>
@@ -25525,6 +25619,1277 @@
 </p:sld>
 </file>
 
+<file path=ppt/slides/slide25.xml><?xml version="1.0" encoding="utf-8"?>
+<p:sld xmlns:a="http://schemas.openxmlformats.org/drawingml/2006/main" xmlns:p="http://schemas.openxmlformats.org/presentationml/2006/main" xmlns:r="http://schemas.openxmlformats.org/officeDocument/2006/relationships">
+  <p:cSld>
+    <p:bg>
+      <p:bgPr>
+        <a:solidFill>
+          <a:srgbClr val="F7F8FA"/>
+        </a:solidFill>
+        <a:effectLst/>
+      </p:bgPr>
+    </p:bg>
+    <p:spTree>
+      <p:nvGrpSpPr>
+        <p:cNvPr id="1" name=""/>
+        <p:cNvGrpSpPr/>
+        <p:nvPr/>
+      </p:nvGrpSpPr>
+      <p:grpSpPr/>
+      <p:sp>
+        <p:nvSpPr>
+          <p:cNvPr id="2" name="Rectangle 1"/>
+          <p:cNvSpPr/>
+          <p:nvPr/>
+        </p:nvSpPr>
+        <p:spPr>
+          <a:xfrm>
+            <a:off x="0" y="0"/>
+            <a:ext cx="12192000" cy="114300"/>
+          </a:xfrm>
+          <a:prstGeom prst="rect">
+            <a:avLst/>
+          </a:prstGeom>
+          <a:solidFill>
+            <a:srgbClr val="233A70"/>
+          </a:solidFill>
+          <a:ln>
+            <a:noFill/>
+          </a:ln>
+        </p:spPr>
+        <p:style>
+          <a:lnRef idx="1">
+            <a:schemeClr val="accent1"/>
+          </a:lnRef>
+          <a:fillRef idx="3">
+            <a:schemeClr val="accent1"/>
+          </a:fillRef>
+          <a:effectRef idx="2">
+            <a:schemeClr val="accent1"/>
+          </a:effectRef>
+          <a:fontRef idx="minor">
+            <a:schemeClr val="lt1"/>
+          </a:fontRef>
+        </p:style>
+        <p:txBody>
+          <a:bodyPr rtlCol="0" anchor="ctr"/>
+          <a:lstStyle/>
+          <a:p>
+            <a:pPr algn="ctr"/>
+          </a:p>
+        </p:txBody>
+      </p:sp>
+      <p:sp>
+        <p:nvSpPr>
+          <p:cNvPr id="3" name="TextBox 2"/>
+          <p:cNvSpPr txBox="1"/>
+          <p:nvPr/>
+        </p:nvSpPr>
+        <p:spPr>
+          <a:xfrm>
+            <a:off x="694944" y="457200"/>
+            <a:ext cx="10789920" cy="566928"/>
+          </a:xfrm>
+          <a:prstGeom prst="rect">
+            <a:avLst/>
+          </a:prstGeom>
+          <a:noFill/>
+        </p:spPr>
+        <p:txBody>
+          <a:bodyPr wrap="square" anchor="t">
+            <a:spAutoFit/>
+          </a:bodyPr>
+          <a:lstStyle/>
+          <a:p>
+            <a:pPr algn="l"/>
+            <a:r>
+              <a:rPr sz="3550" b="1">
+                <a:solidFill>
+                  <a:srgbClr val="233A70"/>
+                </a:solidFill>
+                <a:latin typeface="Arial"/>
+              </a:rPr>
+              <a:t>Weapon, non-weapon and OOD: distinct roles</a:t>
+            </a:r>
+          </a:p>
+        </p:txBody>
+      </p:sp>
+      <p:sp>
+        <p:nvSpPr>
+          <p:cNvPr id="4" name="Rectangle 3"/>
+          <p:cNvSpPr/>
+          <p:nvPr/>
+        </p:nvSpPr>
+        <p:spPr>
+          <a:xfrm>
+            <a:off x="694944" y="1078992"/>
+            <a:ext cx="10826496" cy="18288"/>
+          </a:xfrm>
+          <a:prstGeom prst="rect">
+            <a:avLst/>
+          </a:prstGeom>
+          <a:solidFill>
+            <a:srgbClr val="D9DEE8"/>
+          </a:solidFill>
+          <a:ln>
+            <a:noFill/>
+          </a:ln>
+        </p:spPr>
+        <p:style>
+          <a:lnRef idx="1">
+            <a:schemeClr val="accent1"/>
+          </a:lnRef>
+          <a:fillRef idx="3">
+            <a:schemeClr val="accent1"/>
+          </a:fillRef>
+          <a:effectRef idx="2">
+            <a:schemeClr val="accent1"/>
+          </a:effectRef>
+          <a:fontRef idx="minor">
+            <a:schemeClr val="lt1"/>
+          </a:fontRef>
+        </p:style>
+        <p:txBody>
+          <a:bodyPr rtlCol="0" anchor="ctr"/>
+          <a:lstStyle/>
+          <a:p>
+            <a:pPr algn="ctr"/>
+          </a:p>
+        </p:txBody>
+      </p:sp>
+      <p:sp>
+        <p:nvSpPr>
+          <p:cNvPr id="5" name="Rounded Rectangle 4"/>
+          <p:cNvSpPr/>
+          <p:nvPr/>
+        </p:nvSpPr>
+        <p:spPr>
+          <a:xfrm>
+            <a:off x="694944" y="1481328"/>
+            <a:ext cx="3273552" cy="3886200"/>
+          </a:xfrm>
+          <a:prstGeom prst="roundRect">
+            <a:avLst/>
+          </a:prstGeom>
+          <a:solidFill>
+            <a:srgbClr val="FBEAEA"/>
+          </a:solidFill>
+          <a:ln>
+            <a:solidFill>
+              <a:srgbClr val="FBEAEA"/>
+            </a:solidFill>
+          </a:ln>
+        </p:spPr>
+        <p:style>
+          <a:lnRef idx="1">
+            <a:schemeClr val="accent1"/>
+          </a:lnRef>
+          <a:fillRef idx="3">
+            <a:schemeClr val="accent1"/>
+          </a:fillRef>
+          <a:effectRef idx="2">
+            <a:schemeClr val="accent1"/>
+          </a:effectRef>
+          <a:fontRef idx="minor">
+            <a:schemeClr val="lt1"/>
+          </a:fontRef>
+        </p:style>
+        <p:txBody>
+          <a:bodyPr rtlCol="0" anchor="ctr"/>
+          <a:lstStyle/>
+          <a:p>
+            <a:pPr algn="ctr"/>
+          </a:p>
+        </p:txBody>
+      </p:sp>
+      <p:sp>
+        <p:nvSpPr>
+          <p:cNvPr id="6" name="Rounded Rectangle 5"/>
+          <p:cNvSpPr/>
+          <p:nvPr/>
+        </p:nvSpPr>
+        <p:spPr>
+          <a:xfrm>
+            <a:off x="3136391" y="1636776"/>
+            <a:ext cx="621792" cy="365760"/>
+          </a:xfrm>
+          <a:prstGeom prst="roundRect">
+            <a:avLst/>
+          </a:prstGeom>
+          <a:solidFill>
+            <a:srgbClr val="FFFFFF"/>
+          </a:solidFill>
+          <a:ln>
+            <a:solidFill>
+              <a:srgbClr val="FFFFFF"/>
+            </a:solidFill>
+          </a:ln>
+        </p:spPr>
+        <p:style>
+          <a:lnRef idx="1">
+            <a:schemeClr val="accent1"/>
+          </a:lnRef>
+          <a:fillRef idx="3">
+            <a:schemeClr val="accent1"/>
+          </a:fillRef>
+          <a:effectRef idx="2">
+            <a:schemeClr val="accent1"/>
+          </a:effectRef>
+          <a:fontRef idx="minor">
+            <a:schemeClr val="lt1"/>
+          </a:fontRef>
+        </p:style>
+        <p:txBody>
+          <a:bodyPr rtlCol="0" anchor="ctr"/>
+          <a:lstStyle/>
+          <a:p>
+            <a:pPr algn="ctr"/>
+          </a:p>
+        </p:txBody>
+      </p:sp>
+      <p:sp>
+        <p:nvSpPr>
+          <p:cNvPr id="7" name="TextBox 6"/>
+          <p:cNvSpPr txBox="1"/>
+          <p:nvPr/>
+        </p:nvSpPr>
+        <p:spPr>
+          <a:xfrm>
+            <a:off x="3136391" y="1645920"/>
+            <a:ext cx="621792" cy="320040"/>
+          </a:xfrm>
+          <a:prstGeom prst="rect">
+            <a:avLst/>
+          </a:prstGeom>
+          <a:noFill/>
+        </p:spPr>
+        <p:txBody>
+          <a:bodyPr wrap="square" anchor="ctr">
+            <a:spAutoFit/>
+          </a:bodyPr>
+          <a:lstStyle/>
+          <a:p>
+            <a:pPr algn="ctr"/>
+            <a:r>
+              <a:rPr sz="1300" b="1">
+                <a:solidFill>
+                  <a:srgbClr val="C43D38"/>
+                </a:solidFill>
+                <a:latin typeface="Arial"/>
+              </a:rPr>
+              <a:t>500</a:t>
+            </a:r>
+          </a:p>
+        </p:txBody>
+      </p:sp>
+      <p:pic>
+        <p:nvPicPr>
+          <p:cNvPr id="8" name="Picture 7" descr="gun.png"/>
+          <p:cNvPicPr>
+            <a:picLocks noChangeAspect="1"/>
+          </p:cNvPicPr>
+          <p:nvPr/>
+        </p:nvPicPr>
+        <p:blipFill>
+          <a:blip r:embed="rId2"/>
+          <a:stretch>
+            <a:fillRect/>
+          </a:stretch>
+        </p:blipFill>
+        <p:spPr>
+          <a:xfrm>
+            <a:off x="1773936" y="1865376"/>
+            <a:ext cx="1097280" cy="1097280"/>
+          </a:xfrm>
+          <a:prstGeom prst="rect">
+            <a:avLst/>
+          </a:prstGeom>
+        </p:spPr>
+      </p:pic>
+      <p:sp>
+        <p:nvSpPr>
+          <p:cNvPr id="9" name="TextBox 8"/>
+          <p:cNvSpPr txBox="1"/>
+          <p:nvPr/>
+        </p:nvSpPr>
+        <p:spPr>
+          <a:xfrm>
+            <a:off x="950976" y="2944368"/>
+            <a:ext cx="2761488" cy="411480"/>
+          </a:xfrm>
+          <a:prstGeom prst="rect">
+            <a:avLst/>
+          </a:prstGeom>
+          <a:noFill/>
+        </p:spPr>
+        <p:txBody>
+          <a:bodyPr wrap="square" anchor="t">
+            <a:spAutoFit/>
+          </a:bodyPr>
+          <a:lstStyle/>
+          <a:p>
+            <a:pPr algn="ctr"/>
+            <a:r>
+              <a:rPr sz="2050" b="1">
+                <a:solidFill>
+                  <a:srgbClr val="C43D38"/>
+                </a:solidFill>
+                <a:latin typeface="Arial"/>
+              </a:rPr>
+              <a:t>WEAPON</a:t>
+            </a:r>
+          </a:p>
+        </p:txBody>
+      </p:sp>
+      <p:sp>
+        <p:nvSpPr>
+          <p:cNvPr id="10" name="TextBox 9"/>
+          <p:cNvSpPr txBox="1"/>
+          <p:nvPr/>
+        </p:nvSpPr>
+        <p:spPr>
+          <a:xfrm>
+            <a:off x="950976" y="3383280"/>
+            <a:ext cx="2761488" cy="347472"/>
+          </a:xfrm>
+          <a:prstGeom prst="rect">
+            <a:avLst/>
+          </a:prstGeom>
+          <a:noFill/>
+        </p:spPr>
+        <p:txBody>
+          <a:bodyPr wrap="square" anchor="t">
+            <a:spAutoFit/>
+          </a:bodyPr>
+          <a:lstStyle/>
+          <a:p>
+            <a:pPr algn="ctr"/>
+            <a:r>
+              <a:rPr sz="1250" b="1">
+                <a:solidFill>
+                  <a:srgbClr val="233A70"/>
+                </a:solidFill>
+                <a:latin typeface="Arial"/>
+              </a:rPr>
+              <a:t>IN-DISTRIBUTION POSITIVE</a:t>
+            </a:r>
+          </a:p>
+        </p:txBody>
+      </p:sp>
+      <p:sp>
+        <p:nvSpPr>
+          <p:cNvPr id="11" name="Rectangle 10"/>
+          <p:cNvSpPr/>
+          <p:nvPr/>
+        </p:nvSpPr>
+        <p:spPr>
+          <a:xfrm>
+            <a:off x="1106424" y="3822191"/>
+            <a:ext cx="2450592" cy="13716"/>
+          </a:xfrm>
+          <a:prstGeom prst="rect">
+            <a:avLst/>
+          </a:prstGeom>
+          <a:solidFill>
+            <a:srgbClr val="D9DEE8"/>
+          </a:solidFill>
+          <a:ln>
+            <a:noFill/>
+          </a:ln>
+        </p:spPr>
+        <p:style>
+          <a:lnRef idx="1">
+            <a:schemeClr val="accent1"/>
+          </a:lnRef>
+          <a:fillRef idx="3">
+            <a:schemeClr val="accent1"/>
+          </a:fillRef>
+          <a:effectRef idx="2">
+            <a:schemeClr val="accent1"/>
+          </a:effectRef>
+          <a:fontRef idx="minor">
+            <a:schemeClr val="lt1"/>
+          </a:fontRef>
+        </p:style>
+        <p:txBody>
+          <a:bodyPr rtlCol="0" anchor="ctr"/>
+          <a:lstStyle/>
+          <a:p>
+            <a:pPr algn="ctr"/>
+          </a:p>
+        </p:txBody>
+      </p:sp>
+      <p:sp>
+        <p:nvSpPr>
+          <p:cNvPr id="12" name="TextBox 11"/>
+          <p:cNvSpPr txBox="1"/>
+          <p:nvPr/>
+        </p:nvSpPr>
+        <p:spPr>
+          <a:xfrm>
+            <a:off x="1014983" y="4005072"/>
+            <a:ext cx="2633472" cy="1024128"/>
+          </a:xfrm>
+          <a:prstGeom prst="rect">
+            <a:avLst/>
+          </a:prstGeom>
+          <a:noFill/>
+        </p:spPr>
+        <p:txBody>
+          <a:bodyPr wrap="square" anchor="t">
+            <a:spAutoFit/>
+          </a:bodyPr>
+          <a:lstStyle/>
+          <a:p>
+            <a:pPr algn="ctr"/>
+            <a:r>
+              <a:rPr sz="1240" b="0">
+                <a:solidFill>
+                  <a:srgbClr val="5D6A7F"/>
+                </a:solidFill>
+                <a:latin typeface="Arial"/>
+              </a:rPr>
+              <a:t>Real firearm or firearm-like object, sufficiently visible and relevant to the binary triage task.</a:t>
+            </a:r>
+          </a:p>
+        </p:txBody>
+      </p:sp>
+      <p:sp>
+        <p:nvSpPr>
+          <p:cNvPr id="13" name="Rounded Rectangle 12"/>
+          <p:cNvSpPr/>
+          <p:nvPr/>
+        </p:nvSpPr>
+        <p:spPr>
+          <a:xfrm>
+            <a:off x="4462272" y="1481328"/>
+            <a:ext cx="3273552" cy="3886200"/>
+          </a:xfrm>
+          <a:prstGeom prst="roundRect">
+            <a:avLst/>
+          </a:prstGeom>
+          <a:solidFill>
+            <a:srgbClr val="E7F8F0"/>
+          </a:solidFill>
+          <a:ln>
+            <a:solidFill>
+              <a:srgbClr val="E7F8F0"/>
+            </a:solidFill>
+          </a:ln>
+        </p:spPr>
+        <p:style>
+          <a:lnRef idx="1">
+            <a:schemeClr val="accent1"/>
+          </a:lnRef>
+          <a:fillRef idx="3">
+            <a:schemeClr val="accent1"/>
+          </a:fillRef>
+          <a:effectRef idx="2">
+            <a:schemeClr val="accent1"/>
+          </a:effectRef>
+          <a:fontRef idx="minor">
+            <a:schemeClr val="lt1"/>
+          </a:fontRef>
+        </p:style>
+        <p:txBody>
+          <a:bodyPr rtlCol="0" anchor="ctr"/>
+          <a:lstStyle/>
+          <a:p>
+            <a:pPr algn="ctr"/>
+          </a:p>
+        </p:txBody>
+      </p:sp>
+      <p:sp>
+        <p:nvSpPr>
+          <p:cNvPr id="14" name="Rounded Rectangle 13"/>
+          <p:cNvSpPr/>
+          <p:nvPr/>
+        </p:nvSpPr>
+        <p:spPr>
+          <a:xfrm>
+            <a:off x="6903720" y="1636776"/>
+            <a:ext cx="621792" cy="365760"/>
+          </a:xfrm>
+          <a:prstGeom prst="roundRect">
+            <a:avLst/>
+          </a:prstGeom>
+          <a:solidFill>
+            <a:srgbClr val="FFFFFF"/>
+          </a:solidFill>
+          <a:ln>
+            <a:solidFill>
+              <a:srgbClr val="FFFFFF"/>
+            </a:solidFill>
+          </a:ln>
+        </p:spPr>
+        <p:style>
+          <a:lnRef idx="1">
+            <a:schemeClr val="accent1"/>
+          </a:lnRef>
+          <a:fillRef idx="3">
+            <a:schemeClr val="accent1"/>
+          </a:fillRef>
+          <a:effectRef idx="2">
+            <a:schemeClr val="accent1"/>
+          </a:effectRef>
+          <a:fontRef idx="minor">
+            <a:schemeClr val="lt1"/>
+          </a:fontRef>
+        </p:style>
+        <p:txBody>
+          <a:bodyPr rtlCol="0" anchor="ctr"/>
+          <a:lstStyle/>
+          <a:p>
+            <a:pPr algn="ctr"/>
+          </a:p>
+        </p:txBody>
+      </p:sp>
+      <p:sp>
+        <p:nvSpPr>
+          <p:cNvPr id="15" name="TextBox 14"/>
+          <p:cNvSpPr txBox="1"/>
+          <p:nvPr/>
+        </p:nvSpPr>
+        <p:spPr>
+          <a:xfrm>
+            <a:off x="6903720" y="1645920"/>
+            <a:ext cx="621792" cy="320040"/>
+          </a:xfrm>
+          <a:prstGeom prst="rect">
+            <a:avLst/>
+          </a:prstGeom>
+          <a:noFill/>
+        </p:spPr>
+        <p:txBody>
+          <a:bodyPr wrap="square" anchor="ctr">
+            <a:spAutoFit/>
+          </a:bodyPr>
+          <a:lstStyle/>
+          <a:p>
+            <a:pPr algn="ctr"/>
+            <a:r>
+              <a:rPr sz="1300" b="1">
+                <a:solidFill>
+                  <a:srgbClr val="007F5C"/>
+                </a:solidFill>
+                <a:latin typeface="Arial"/>
+              </a:rPr>
+              <a:t>500</a:t>
+            </a:r>
+          </a:p>
+        </p:txBody>
+      </p:sp>
+      <p:pic>
+        <p:nvPicPr>
+          <p:cNvPr id="16" name="Picture 15" descr="mug.png"/>
+          <p:cNvPicPr>
+            <a:picLocks noChangeAspect="1"/>
+          </p:cNvPicPr>
+          <p:nvPr/>
+        </p:nvPicPr>
+        <p:blipFill>
+          <a:blip r:embed="rId3"/>
+          <a:stretch>
+            <a:fillRect/>
+          </a:stretch>
+        </p:blipFill>
+        <p:spPr>
+          <a:xfrm>
+            <a:off x="5541264" y="1865376"/>
+            <a:ext cx="1097280" cy="1097280"/>
+          </a:xfrm>
+          <a:prstGeom prst="rect">
+            <a:avLst/>
+          </a:prstGeom>
+        </p:spPr>
+      </p:pic>
+      <p:sp>
+        <p:nvSpPr>
+          <p:cNvPr id="17" name="TextBox 16"/>
+          <p:cNvSpPr txBox="1"/>
+          <p:nvPr/>
+        </p:nvSpPr>
+        <p:spPr>
+          <a:xfrm>
+            <a:off x="4718304" y="2944368"/>
+            <a:ext cx="2761488" cy="411480"/>
+          </a:xfrm>
+          <a:prstGeom prst="rect">
+            <a:avLst/>
+          </a:prstGeom>
+          <a:noFill/>
+        </p:spPr>
+        <p:txBody>
+          <a:bodyPr wrap="square" anchor="t">
+            <a:spAutoFit/>
+          </a:bodyPr>
+          <a:lstStyle/>
+          <a:p>
+            <a:pPr algn="ctr"/>
+            <a:r>
+              <a:rPr sz="2050" b="1">
+                <a:solidFill>
+                  <a:srgbClr val="007F5C"/>
+                </a:solidFill>
+                <a:latin typeface="Arial"/>
+              </a:rPr>
+              <a:t>NON-WEAPON</a:t>
+            </a:r>
+          </a:p>
+        </p:txBody>
+      </p:sp>
+      <p:sp>
+        <p:nvSpPr>
+          <p:cNvPr id="18" name="TextBox 17"/>
+          <p:cNvSpPr txBox="1"/>
+          <p:nvPr/>
+        </p:nvSpPr>
+        <p:spPr>
+          <a:xfrm>
+            <a:off x="4718304" y="3383280"/>
+            <a:ext cx="2761488" cy="347472"/>
+          </a:xfrm>
+          <a:prstGeom prst="rect">
+            <a:avLst/>
+          </a:prstGeom>
+          <a:noFill/>
+        </p:spPr>
+        <p:txBody>
+          <a:bodyPr wrap="square" anchor="t">
+            <a:spAutoFit/>
+          </a:bodyPr>
+          <a:lstStyle/>
+          <a:p>
+            <a:pPr algn="ctr"/>
+            <a:r>
+              <a:rPr sz="1250" b="1">
+                <a:solidFill>
+                  <a:srgbClr val="233A70"/>
+                </a:solidFill>
+                <a:latin typeface="Arial"/>
+              </a:rPr>
+              <a:t>IN-DISTRIBUTION NEGATIVE</a:t>
+            </a:r>
+          </a:p>
+        </p:txBody>
+      </p:sp>
+      <p:sp>
+        <p:nvSpPr>
+          <p:cNvPr id="19" name="Rectangle 18"/>
+          <p:cNvSpPr/>
+          <p:nvPr/>
+        </p:nvSpPr>
+        <p:spPr>
+          <a:xfrm>
+            <a:off x="4873752" y="3822191"/>
+            <a:ext cx="2450592" cy="13716"/>
+          </a:xfrm>
+          <a:prstGeom prst="rect">
+            <a:avLst/>
+          </a:prstGeom>
+          <a:solidFill>
+            <a:srgbClr val="D9DEE8"/>
+          </a:solidFill>
+          <a:ln>
+            <a:noFill/>
+          </a:ln>
+        </p:spPr>
+        <p:style>
+          <a:lnRef idx="1">
+            <a:schemeClr val="accent1"/>
+          </a:lnRef>
+          <a:fillRef idx="3">
+            <a:schemeClr val="accent1"/>
+          </a:fillRef>
+          <a:effectRef idx="2">
+            <a:schemeClr val="accent1"/>
+          </a:effectRef>
+          <a:fontRef idx="minor">
+            <a:schemeClr val="lt1"/>
+          </a:fontRef>
+        </p:style>
+        <p:txBody>
+          <a:bodyPr rtlCol="0" anchor="ctr"/>
+          <a:lstStyle/>
+          <a:p>
+            <a:pPr algn="ctr"/>
+          </a:p>
+        </p:txBody>
+      </p:sp>
+      <p:sp>
+        <p:nvSpPr>
+          <p:cNvPr id="20" name="TextBox 19"/>
+          <p:cNvSpPr txBox="1"/>
+          <p:nvPr/>
+        </p:nvSpPr>
+        <p:spPr>
+          <a:xfrm>
+            <a:off x="4782312" y="4005072"/>
+            <a:ext cx="2633472" cy="1024128"/>
+          </a:xfrm>
+          <a:prstGeom prst="rect">
+            <a:avLst/>
+          </a:prstGeom>
+          <a:noFill/>
+        </p:spPr>
+        <p:txBody>
+          <a:bodyPr wrap="square" anchor="t">
+            <a:spAutoFit/>
+          </a:bodyPr>
+          <a:lstStyle/>
+          <a:p>
+            <a:pPr algn="ctr"/>
+            <a:r>
+              <a:rPr sz="1240" b="0">
+                <a:solidFill>
+                  <a:srgbClr val="5D6A7F"/>
+                </a:solidFill>
+                <a:latin typeface="Arial"/>
+              </a:rPr>
+              <a:t>Realistic image with no firearm, still compatible with the visual domain of the binary task.</a:t>
+            </a:r>
+          </a:p>
+        </p:txBody>
+      </p:sp>
+      <p:sp>
+        <p:nvSpPr>
+          <p:cNvPr id="21" name="Rounded Rectangle 20"/>
+          <p:cNvSpPr/>
+          <p:nvPr/>
+        </p:nvSpPr>
+        <p:spPr>
+          <a:xfrm>
+            <a:off x="8229600" y="1481328"/>
+            <a:ext cx="3273552" cy="3886200"/>
+          </a:xfrm>
+          <a:prstGeom prst="roundRect">
+            <a:avLst/>
+          </a:prstGeom>
+          <a:solidFill>
+            <a:srgbClr val="FFF4CD"/>
+          </a:solidFill>
+          <a:ln>
+            <a:solidFill>
+              <a:srgbClr val="FFF4CD"/>
+            </a:solidFill>
+          </a:ln>
+        </p:spPr>
+        <p:style>
+          <a:lnRef idx="1">
+            <a:schemeClr val="accent1"/>
+          </a:lnRef>
+          <a:fillRef idx="3">
+            <a:schemeClr val="accent1"/>
+          </a:fillRef>
+          <a:effectRef idx="2">
+            <a:schemeClr val="accent1"/>
+          </a:effectRef>
+          <a:fontRef idx="minor">
+            <a:schemeClr val="lt1"/>
+          </a:fontRef>
+        </p:style>
+        <p:txBody>
+          <a:bodyPr rtlCol="0" anchor="ctr"/>
+          <a:lstStyle/>
+          <a:p>
+            <a:pPr algn="ctr"/>
+          </a:p>
+        </p:txBody>
+      </p:sp>
+      <p:sp>
+        <p:nvSpPr>
+          <p:cNvPr id="22" name="Rounded Rectangle 21"/>
+          <p:cNvSpPr/>
+          <p:nvPr/>
+        </p:nvSpPr>
+        <p:spPr>
+          <a:xfrm>
+            <a:off x="10671048" y="1636776"/>
+            <a:ext cx="621792" cy="365760"/>
+          </a:xfrm>
+          <a:prstGeom prst="roundRect">
+            <a:avLst/>
+          </a:prstGeom>
+          <a:solidFill>
+            <a:srgbClr val="FFFFFF"/>
+          </a:solidFill>
+          <a:ln>
+            <a:solidFill>
+              <a:srgbClr val="FFFFFF"/>
+            </a:solidFill>
+          </a:ln>
+        </p:spPr>
+        <p:style>
+          <a:lnRef idx="1">
+            <a:schemeClr val="accent1"/>
+          </a:lnRef>
+          <a:fillRef idx="3">
+            <a:schemeClr val="accent1"/>
+          </a:fillRef>
+          <a:effectRef idx="2">
+            <a:schemeClr val="accent1"/>
+          </a:effectRef>
+          <a:fontRef idx="minor">
+            <a:schemeClr val="lt1"/>
+          </a:fontRef>
+        </p:style>
+        <p:txBody>
+          <a:bodyPr rtlCol="0" anchor="ctr"/>
+          <a:lstStyle/>
+          <a:p>
+            <a:pPr algn="ctr"/>
+          </a:p>
+        </p:txBody>
+      </p:sp>
+      <p:sp>
+        <p:nvSpPr>
+          <p:cNvPr id="23" name="TextBox 22"/>
+          <p:cNvSpPr txBox="1"/>
+          <p:nvPr/>
+        </p:nvSpPr>
+        <p:spPr>
+          <a:xfrm>
+            <a:off x="10671048" y="1645920"/>
+            <a:ext cx="621792" cy="320040"/>
+          </a:xfrm>
+          <a:prstGeom prst="rect">
+            <a:avLst/>
+          </a:prstGeom>
+          <a:noFill/>
+        </p:spPr>
+        <p:txBody>
+          <a:bodyPr wrap="square" anchor="ctr">
+            <a:spAutoFit/>
+          </a:bodyPr>
+          <a:lstStyle/>
+          <a:p>
+            <a:pPr algn="ctr"/>
+            <a:r>
+              <a:rPr sz="1300" b="1">
+                <a:solidFill>
+                  <a:srgbClr val="C99500"/>
+                </a:solidFill>
+                <a:latin typeface="Arial"/>
+              </a:rPr>
+              <a:t>500</a:t>
+            </a:r>
+          </a:p>
+        </p:txBody>
+      </p:sp>
+      <p:pic>
+        <p:nvPicPr>
+          <p:cNvPr id="24" name="Picture 23" descr="gamepad.png"/>
+          <p:cNvPicPr>
+            <a:picLocks noChangeAspect="1"/>
+          </p:cNvPicPr>
+          <p:nvPr/>
+        </p:nvPicPr>
+        <p:blipFill>
+          <a:blip r:embed="rId4"/>
+          <a:stretch>
+            <a:fillRect/>
+          </a:stretch>
+        </p:blipFill>
+        <p:spPr>
+          <a:xfrm>
+            <a:off x="8796528" y="1984248"/>
+            <a:ext cx="685800" cy="685800"/>
+          </a:xfrm>
+          <a:prstGeom prst="rect">
+            <a:avLst/>
+          </a:prstGeom>
+        </p:spPr>
+      </p:pic>
+      <p:pic>
+        <p:nvPicPr>
+          <p:cNvPr id="25" name="Picture 24" descr="robot.png"/>
+          <p:cNvPicPr>
+            <a:picLocks noChangeAspect="1"/>
+          </p:cNvPicPr>
+          <p:nvPr/>
+        </p:nvPicPr>
+        <p:blipFill>
+          <a:blip r:embed="rId5"/>
+          <a:stretch>
+            <a:fillRect/>
+          </a:stretch>
+        </p:blipFill>
+        <p:spPr>
+          <a:xfrm>
+            <a:off x="9509760" y="1801368"/>
+            <a:ext cx="822960" cy="822960"/>
+          </a:xfrm>
+          <a:prstGeom prst="rect">
+            <a:avLst/>
+          </a:prstGeom>
+        </p:spPr>
+      </p:pic>
+      <p:pic>
+        <p:nvPicPr>
+          <p:cNvPr id="26" name="Picture 25" descr="warn.png"/>
+          <p:cNvPicPr>
+            <a:picLocks noChangeAspect="1"/>
+          </p:cNvPicPr>
+          <p:nvPr/>
+        </p:nvPicPr>
+        <p:blipFill>
+          <a:blip r:embed="rId6"/>
+          <a:stretch>
+            <a:fillRect/>
+          </a:stretch>
+        </p:blipFill>
+        <p:spPr>
+          <a:xfrm>
+            <a:off x="10222992" y="1984248"/>
+            <a:ext cx="685800" cy="685800"/>
+          </a:xfrm>
+          <a:prstGeom prst="rect">
+            <a:avLst/>
+          </a:prstGeom>
+        </p:spPr>
+      </p:pic>
+      <p:sp>
+        <p:nvSpPr>
+          <p:cNvPr id="27" name="TextBox 26"/>
+          <p:cNvSpPr txBox="1"/>
+          <p:nvPr/>
+        </p:nvSpPr>
+        <p:spPr>
+          <a:xfrm>
+            <a:off x="8485632" y="2944368"/>
+            <a:ext cx="2761488" cy="411480"/>
+          </a:xfrm>
+          <a:prstGeom prst="rect">
+            <a:avLst/>
+          </a:prstGeom>
+          <a:noFill/>
+        </p:spPr>
+        <p:txBody>
+          <a:bodyPr wrap="square" anchor="t">
+            <a:spAutoFit/>
+          </a:bodyPr>
+          <a:lstStyle/>
+          <a:p>
+            <a:pPr algn="ctr"/>
+            <a:r>
+              <a:rPr sz="2050" b="1">
+                <a:solidFill>
+                  <a:srgbClr val="C99500"/>
+                </a:solidFill>
+                <a:latin typeface="Arial"/>
+              </a:rPr>
+              <a:t>OOD</a:t>
+            </a:r>
+          </a:p>
+        </p:txBody>
+      </p:sp>
+      <p:sp>
+        <p:nvSpPr>
+          <p:cNvPr id="28" name="TextBox 27"/>
+          <p:cNvSpPr txBox="1"/>
+          <p:nvPr/>
+        </p:nvSpPr>
+        <p:spPr>
+          <a:xfrm>
+            <a:off x="8485632" y="3383280"/>
+            <a:ext cx="2761488" cy="347472"/>
+          </a:xfrm>
+          <a:prstGeom prst="rect">
+            <a:avLst/>
+          </a:prstGeom>
+          <a:noFill/>
+        </p:spPr>
+        <p:txBody>
+          <a:bodyPr wrap="square" anchor="t">
+            <a:spAutoFit/>
+          </a:bodyPr>
+          <a:lstStyle/>
+          <a:p>
+            <a:pPr algn="ctr"/>
+            <a:r>
+              <a:rPr sz="1250" b="1">
+                <a:solidFill>
+                  <a:srgbClr val="233A70"/>
+                </a:solidFill>
+                <a:latin typeface="Arial"/>
+              </a:rPr>
+              <a:t>SEPARATE ROBUSTNESS BRANCH</a:t>
+            </a:r>
+          </a:p>
+        </p:txBody>
+      </p:sp>
+      <p:sp>
+        <p:nvSpPr>
+          <p:cNvPr id="29" name="Rectangle 28"/>
+          <p:cNvSpPr/>
+          <p:nvPr/>
+        </p:nvSpPr>
+        <p:spPr>
+          <a:xfrm>
+            <a:off x="8641080" y="3822191"/>
+            <a:ext cx="2450592" cy="13716"/>
+          </a:xfrm>
+          <a:prstGeom prst="rect">
+            <a:avLst/>
+          </a:prstGeom>
+          <a:solidFill>
+            <a:srgbClr val="D9DEE8"/>
+          </a:solidFill>
+          <a:ln>
+            <a:noFill/>
+          </a:ln>
+        </p:spPr>
+        <p:style>
+          <a:lnRef idx="1">
+            <a:schemeClr val="accent1"/>
+          </a:lnRef>
+          <a:fillRef idx="3">
+            <a:schemeClr val="accent1"/>
+          </a:fillRef>
+          <a:effectRef idx="2">
+            <a:schemeClr val="accent1"/>
+          </a:effectRef>
+          <a:fontRef idx="minor">
+            <a:schemeClr val="lt1"/>
+          </a:fontRef>
+        </p:style>
+        <p:txBody>
+          <a:bodyPr rtlCol="0" anchor="ctr"/>
+          <a:lstStyle/>
+          <a:p>
+            <a:pPr algn="ctr"/>
+          </a:p>
+        </p:txBody>
+      </p:sp>
+      <p:sp>
+        <p:nvSpPr>
+          <p:cNvPr id="30" name="TextBox 29"/>
+          <p:cNvSpPr txBox="1"/>
+          <p:nvPr/>
+        </p:nvSpPr>
+        <p:spPr>
+          <a:xfrm>
+            <a:off x="8549640" y="4005072"/>
+            <a:ext cx="2633472" cy="1024128"/>
+          </a:xfrm>
+          <a:prstGeom prst="rect">
+            <a:avLst/>
+          </a:prstGeom>
+          <a:noFill/>
+        </p:spPr>
+        <p:txBody>
+          <a:bodyPr wrap="square" anchor="t">
+            <a:spAutoFit/>
+          </a:bodyPr>
+          <a:lstStyle/>
+          <a:p>
+            <a:pPr algn="ctr"/>
+            <a:r>
+              <a:rPr sz="1240" b="0">
+                <a:solidFill>
+                  <a:srgbClr val="5D6A7F"/>
+                </a:solidFill>
+                <a:latin typeface="Arial"/>
+              </a:rPr>
+              <a:t>Borderline, synthetic, degraded, ambiguous or semantically external inputs: e.g., toys/replicas, CGI/cartoon, non-firearm weapons or war imagery.</a:t>
+            </a:r>
+          </a:p>
+        </p:txBody>
+      </p:sp>
+      <p:sp>
+        <p:nvSpPr>
+          <p:cNvPr id="31" name="Rounded Rectangle 30"/>
+          <p:cNvSpPr/>
+          <p:nvPr/>
+        </p:nvSpPr>
+        <p:spPr>
+          <a:xfrm>
+            <a:off x="694944" y="5577840"/>
+            <a:ext cx="10808208" cy="658368"/>
+          </a:xfrm>
+          <a:prstGeom prst="roundRect">
+            <a:avLst/>
+          </a:prstGeom>
+          <a:solidFill>
+            <a:srgbClr val="E9EEF8"/>
+          </a:solidFill>
+          <a:ln>
+            <a:solidFill>
+              <a:srgbClr val="E9EEF8"/>
+            </a:solidFill>
+          </a:ln>
+        </p:spPr>
+        <p:style>
+          <a:lnRef idx="1">
+            <a:schemeClr val="accent1"/>
+          </a:lnRef>
+          <a:fillRef idx="3">
+            <a:schemeClr val="accent1"/>
+          </a:fillRef>
+          <a:effectRef idx="2">
+            <a:schemeClr val="accent1"/>
+          </a:effectRef>
+          <a:fontRef idx="minor">
+            <a:schemeClr val="lt1"/>
+          </a:fontRef>
+        </p:style>
+        <p:txBody>
+          <a:bodyPr rtlCol="0" anchor="ctr"/>
+          <a:lstStyle/>
+          <a:p>
+            <a:pPr algn="ctr"/>
+          </a:p>
+        </p:txBody>
+      </p:sp>
+      <p:sp>
+        <p:nvSpPr>
+          <p:cNvPr id="32" name="TextBox 31"/>
+          <p:cNvSpPr txBox="1"/>
+          <p:nvPr/>
+        </p:nvSpPr>
+        <p:spPr>
+          <a:xfrm>
+            <a:off x="914400" y="5687568"/>
+            <a:ext cx="10378440" cy="329184"/>
+          </a:xfrm>
+          <a:prstGeom prst="rect">
+            <a:avLst/>
+          </a:prstGeom>
+          <a:noFill/>
+        </p:spPr>
+        <p:txBody>
+          <a:bodyPr wrap="square" anchor="ctr">
+            <a:spAutoFit/>
+          </a:bodyPr>
+          <a:lstStyle/>
+          <a:p>
+            <a:pPr algn="ctr"/>
+            <a:r>
+              <a:rPr sz="1420" b="1">
+                <a:solidFill>
+                  <a:srgbClr val="233A70"/>
+                </a:solidFill>
+                <a:latin typeface="Arial"/>
+              </a:rPr>
+              <a:t>Binary task = weapon vs non_weapon   |   OOD is not a third supervised class and is evaluated separately.</a:t>
+            </a:r>
+          </a:p>
+        </p:txBody>
+      </p:sp>
+      <p:sp>
+        <p:nvSpPr>
+          <p:cNvPr id="33" name="TextBox 32"/>
+          <p:cNvSpPr txBox="1"/>
+          <p:nvPr/>
+        </p:nvSpPr>
+        <p:spPr>
+          <a:xfrm>
+            <a:off x="694944" y="6510528"/>
+            <a:ext cx="3657600" cy="182880"/>
+          </a:xfrm>
+          <a:prstGeom prst="rect">
+            <a:avLst/>
+          </a:prstGeom>
+          <a:noFill/>
+        </p:spPr>
+        <p:txBody>
+          <a:bodyPr wrap="square" anchor="t">
+            <a:spAutoFit/>
+          </a:bodyPr>
+          <a:lstStyle/>
+          <a:p>
+            <a:pPr algn="l"/>
+            <a:r>
+              <a:rPr sz="850" b="0">
+                <a:solidFill>
+                  <a:srgbClr val="5D6A7F"/>
+                </a:solidFill>
+                <a:latin typeface="Arial"/>
+              </a:rPr>
+              <a:t>Illustrative icons — not dataset samples</a:t>
+            </a:r>
+          </a:p>
+        </p:txBody>
+      </p:sp>
+      <p:sp>
+        <p:nvSpPr>
+          <p:cNvPr id="34" name="TextBox 33"/>
+          <p:cNvSpPr txBox="1"/>
+          <p:nvPr/>
+        </p:nvSpPr>
+        <p:spPr>
+          <a:xfrm>
+            <a:off x="694944" y="6620256"/>
+            <a:ext cx="3657600" cy="201168"/>
+          </a:xfrm>
+          <a:prstGeom prst="rect">
+            <a:avLst/>
+          </a:prstGeom>
+          <a:noFill/>
+        </p:spPr>
+        <p:txBody>
+          <a:bodyPr wrap="square" anchor="t">
+            <a:spAutoFit/>
+          </a:bodyPr>
+          <a:lstStyle/>
+          <a:p>
+            <a:pPr algn="l"/>
+            <a:r>
+              <a:rPr sz="1050" b="0">
+                <a:solidFill>
+                  <a:srgbClr val="5D6A7F"/>
+                </a:solidFill>
+                <a:latin typeface="Arial"/>
+              </a:rPr>
+              <a:t>Lello Molinario  |  MSc Thesis Defense</a:t>
+            </a:r>
+          </a:p>
+        </p:txBody>
+      </p:sp>
+      <p:sp>
+        <p:nvSpPr>
+          <p:cNvPr id="35" name="TextBox 34"/>
+          <p:cNvSpPr txBox="1"/>
+          <p:nvPr/>
+        </p:nvSpPr>
+        <p:spPr>
+          <a:xfrm>
+            <a:off x="10991088" y="6528816"/>
+            <a:ext cx="566928" cy="256032"/>
+          </a:xfrm>
+          <a:prstGeom prst="rect">
+            <a:avLst/>
+          </a:prstGeom>
+          <a:noFill/>
+        </p:spPr>
+        <p:txBody>
+          <a:bodyPr wrap="square" anchor="t">
+            <a:spAutoFit/>
+          </a:bodyPr>
+          <a:lstStyle/>
+          <a:p>
+            <a:pPr algn="ctr"/>
+            <a:r>
+              <a:rPr sz="1500">
+                <a:solidFill>
+                  <a:srgbClr val="182235"/>
+                </a:solidFill>
+                <a:latin typeface="Arial"/>
+              </a:rPr>
+              <a:t>05</a:t>
+            </a:r>
+          </a:p>
+        </p:txBody>
+      </p:sp>
+    </p:spTree>
+  </p:cSld>
+  <p:clrMapOvr>
+    <a:masterClrMapping/>
+  </p:clrMapOvr>
+</p:sld>
+</file>
+
 <file path=ppt/slides/slide3.xml><?xml version="1.0" encoding="utf-8"?>
 <p:sld xmlns:a="http://schemas.openxmlformats.org/drawingml/2006/main" xmlns:r="http://schemas.openxmlformats.org/officeDocument/2006/relationships" xmlns:p="http://schemas.openxmlformats.org/presentationml/2006/main">
   <p:cSld>
@@ -28702,8 +30067,15 @@
           </a:bodyPr>
           <a:lstStyle/>
           <a:p>
-            <a:r>
-              <a:t>05</a:t>
+            <a:pPr algn="ctr"/>
+            <a:r>
+              <a:rPr sz="1500">
+                <a:solidFill>
+                  <a:srgbClr val="182235"/>
+                </a:solidFill>
+                <a:latin typeface="Arial"/>
+              </a:rPr>
+              <a:t>06</a:t>
             </a:r>
           </a:p>
         </p:txBody>
@@ -30063,8 +31435,15 @@
           </a:bodyPr>
           <a:lstStyle/>
           <a:p>
-            <a:r>
-              <a:t>06</a:t>
+            <a:pPr algn="ctr"/>
+            <a:r>
+              <a:rPr sz="1500">
+                <a:solidFill>
+                  <a:srgbClr val="182235"/>
+                </a:solidFill>
+                <a:latin typeface="Arial"/>
+              </a:rPr>
+              <a:t>07</a:t>
             </a:r>
           </a:p>
         </p:txBody>
@@ -31462,8 +32841,15 @@
           </a:bodyPr>
           <a:lstStyle/>
           <a:p>
-            <a:r>
-              <a:t>07</a:t>
+            <a:pPr algn="ctr"/>
+            <a:r>
+              <a:rPr sz="1500">
+                <a:solidFill>
+                  <a:srgbClr val="182235"/>
+                </a:solidFill>
+                <a:latin typeface="Arial"/>
+              </a:rPr>
+              <a:t>08</a:t>
             </a:r>
           </a:p>
         </p:txBody>
@@ -33337,8 +34723,15 @@
           </a:bodyPr>
           <a:lstStyle/>
           <a:p>
-            <a:r>
-              <a:t>08</a:t>
+            <a:pPr algn="ctr"/>
+            <a:r>
+              <a:rPr sz="1500">
+                <a:solidFill>
+                  <a:srgbClr val="182235"/>
+                </a:solidFill>
+                <a:latin typeface="Arial"/>
+              </a:rPr>
+              <a:t>09</a:t>
             </a:r>
           </a:p>
         </p:txBody>
@@ -33792,8 +35185,15 @@
           </a:bodyPr>
           <a:lstStyle/>
           <a:p>
-            <a:r>
-              <a:t>09</a:t>
+            <a:pPr algn="ctr"/>
+            <a:r>
+              <a:rPr sz="1500">
+                <a:solidFill>
+                  <a:srgbClr val="182235"/>
+                </a:solidFill>
+                <a:latin typeface="Arial"/>
+              </a:rPr>
+              <a:t>10</a:t>
             </a:r>
           </a:p>
         </p:txBody>

</xml_diff>

<commit_message>
Align defense slides and notes with reviewed thesis claims
</commit_message>
<xml_diff>
--- a/Molinario_Thesis_Defense_2026.pptx
+++ b/Molinario_Thesis_Defense_2026.pptx
@@ -1960,7 +1960,7 @@
           </a:p>
           <a:p>
             <a:r>
-              <a:t>The main limitations are the 1,500-image corpus with one reviewer, one frozen parameter setting for each perturbation condition, direct model-dependent attacks only against EfficientNet-B0, and commercial outputs that depend on the specific tool version and configuration.</a:t>
+              <a:t>The main limitations are the 1,500-image corpus with one reviewer, one setting per perturbation, the bounded One Pixel search, and generation only on EfficientNet-B0. SuperDeepFool results concern an internal single-cycle L2 adapter rather than the full published method. Commercial responses also depend on tool version, configuration, output mapping, and representation differences from native clean inputs.</a:t>
             </a:r>
           </a:p>
           <a:p>
@@ -1989,7 +1989,7 @@
           </a:p>
           <a:p>
             <a:r>
-              <a:t>1,500 / one reviewer → frozen settings → direct target only EfficientNet → version-dependent black-box → metadata caveat → no legal claim</a:t>
+              <a:t>1,500 / one reviewer → fixed budgets → internal SDF adapter → EfficientNet source → representation caveat → no legal claim</a:t>
             </a:r>
           </a:p>
           <a:p>
@@ -2113,7 +2113,7 @@
           <a:p>
             <a:r>
               <a:rPr dirty="0"/>
-              <a:t>Second, direct attacks, empirical transfer, out-of-distribution behavior, and configuration trade-offs are different dimensions and should not be mixed into one single measure.</a:t>
+              <a:t>Second, source-model evaluation, cross-model transfer, commercial responses, out-of-distribution behavior, and configuration trade-offs are different dimensions and should be interpreted separately.</a:t>
             </a:r>
           </a:p>
           <a:p>
@@ -2436,7 +2436,7 @@
           </a:p>
           <a:p>
             <a:r>
-              <a:t>The thesis has four research questions. RQ1 evaluates whether the proxy models maintain clean-baseline performance under separate OOD, adversarial, and anti-forensic conditions. RQ2 separates direct source-model attacks, cross-architecture transfer, and model-agnostic Color Shift. RQ3 examines how black-box outputs and configuration choices shape the observed operational profiles. RQ4 focuses on which directional errors, degradations, OOD assignments, and unknown states matter for continued human review.</a:t>
+              <a:t>The thesis has four research questions. RQ1 evaluates proxy behavior under separate OOD, adversarial, and anti-forensic conditions. RQ2 compares proxy responses under source-model evaluation, empirical cross-model transfer, and model-agnostic Color Shift. RQ3 examines black-box outputs and configuration-dependent profiles. RQ4 addresses directional errors, degradations, OOD assignments, and unknown states relevant to continued human review.</a:t>
             </a:r>
           </a:p>
           <a:p>
@@ -2457,7 +2457,7 @@
           </a:p>
           <a:p>
             <a:r>
-              <a:t>RQ1 robustness conditions → RQ2 direct vs transfer → RQ3 black-box configuration → RQ4 operational risk → protocol-specific scope</a:t>
+              <a:t>RQ1 conditions → RQ2 source evaluation / cross-model transfer / Color Shift → RQ3 configurations → RQ4 directional errors</a:t>
             </a:r>
           </a:p>
         </p:txBody>
@@ -2568,7 +2568,7 @@
           </a:p>
           <a:p>
             <a:r>
-              <a:t>The critical distinction is the threat path. Model-dependent attacks are generated directly only against EfficientNet-B0. When those same files are evaluated on ResNet18, CLIP, or the commercial systems, the result is empirical transfer. Color Shift and all five anti-forensic transformations are model-agnostic conditions.</a:t>
+              <a:t>Attack knowledge is gradient-based for FGSM, Sigma Zero, and the internal SuperDeepFool adapter, and score-based for One Pixel. All three proxies are inspectable and white-box-capable, but only EfficientNet-B0 was used for model-dependent generation. ResNet18 and CLIP measure cross-model transfer; commercial systems provide empirical responses. Color Shift and the anti-forensic transformations are model-agnostic.</a:t>
             </a:r>
           </a:p>
           <a:p>
@@ -2581,7 +2581,7 @@
           </a:p>
           <a:p>
             <a:r>
-              <a:t>5 adversarial/adversarial-style → 5 anti-forensic → direct only EfficientNet-B0 → transfer elsewhere → model-agnostic Color Shift/AF</a:t>
+              <a:t>gradient-based / score-based / model-agnostic → EfficientNet source → proxy transfer → commercial response</a:t>
             </a:r>
           </a:p>
         </p:txBody>
@@ -3114,7 +3114,7 @@
           </a:p>
           <a:p>
             <a:r>
-              <a:t>All adversarial settings were frozen before evaluation. FGSM is untargeted with epsilon equal to 8 over 255 in pixel space and uses the fold-aware white-box EfficientNet-B0 checkpoint. One Pixel uses differential evolution over x, y, R, G, and B, with 50 iterations, an effective population of about 100, seed 42, and early stopping after misclassification.</a:t>
+              <a:t>FGSM uses a fixed epsilon of 8/255, with precedent in RobustBench CIFAR evaluation; this is not a forensic standard, and no epsilon sweep was performed. One Pixel uses score-based Differential Evolution over x, y, R, G, and B, with 50 maximum iterations, 100 candidates, seed 42, and stopping at a generation boundary after misclassification. This is a smaller budget than the original 400-candidate, 100-iteration setting; limited effectiveness does not establish general robustness.</a:t>
             </a:r>
           </a:p>
           <a:p>
@@ -3122,7 +3122,7 @@
           </a:p>
           <a:p>
             <a:r>
-              <a:t>Sigma Zero uses 1,000 steps with eta zero 1.0, sigma 0.001, and tau zero 0.3. SuperDeepFool uses SDF infinity-one, with 20 outer iterations, 50 inner DeepFool iterations, and one projection step. Color Shift is deterministic and model-agnostic.</a:t>
+              <a:t>Sigma Zero uses the defaults of the pinned adversarial-library reference function: 1,000 steps, eta zero 1.0, sigma 0.001, tau zero 0.3, threshold factor 0.01, and infinity-norm gradient normalization. The internal SuperDeepFool adapter uses L2 geometry, at most 50 DeepFool iterations, and one projection. Although the configured outer cap is 20, all 1,000 records show one executed cycle; failed projection falls back to the boundary point. This differs from the repeated boundary/projection procedure of published SDF infinity-one. Infinity denotes the inner iteration variant, not an L-infinity perturbation norm. Results describe this bounded internal adapter; Color Shift remains model-agnostic.</a:t>
             </a:r>
           </a:p>
           <a:p>
@@ -3135,7 +3135,7 @@
           </a:p>
           <a:p>
             <a:r>
-              <a:t>FGSM 8/255 → One Pixel DE 50/100 seed42 → Sigma Zero 1000 steps → SDF 20/50/1 → EfficientNet target</a:t>
+              <a:t>FGSM fixed 8/255 → One Pixel bounded 50/100 → Sigma Zero reference defaults → SDF internal L2 / one cycle</a:t>
             </a:r>
           </a:p>
         </p:txBody>
@@ -3246,7 +3246,7 @@
           </a:p>
           <a:p>
             <a:r>
-              <a:t>The transformations other than the dedicated JPEG recompression condition are serialized at JPEG quality 95. Each condition contains 1,000 source-linked artifacts, so comparisons remain paired to the same binary source population.</a:t>
+              <a:t>The other transformations use JPEG quality 95. Each condition contains 1,000 source-linked artifacts for controlled paired comparison at one predefined setting. These results characterize the tested conditions, not a complete severity-response curve.</a:t>
             </a:r>
           </a:p>
           <a:p>
@@ -3618,7 +3618,7 @@
           </a:p>
           <a:p>
             <a:r>
-              <a:t>Generalizability must be tested rather than assumed from one frozen protocol. The next validation steps are to use larger and more heterogeneous datasets with multiple reviewers, perform parameter sweeps and adaptive attacks, repeat the evaluation across new commercial-tool versions to measure drift, extend the protocol beyond still images, and strengthen audit and human-review controls.</a:t>
+              <a:t>Further validation should use larger and more heterogeneous datasets with multiple reviewers, test parameter sweeps and matched attacks, evaluate the full iterative SuperDeepFool method, and include representation-matched clean controls. It should also repeat commercial evaluations across versions, extend beyond still images, and strengthen audit and human-review controls. These are future experiments, not results of the current study.</a:t>
             </a:r>
           </a:p>
           <a:p>
@@ -4189,23 +4189,23 @@
           <a:p>
             <a:r>
               <a:rPr dirty="0"/>
-              <a:t>The first level consists of three transparent proxy models: EfficientNet-B0, ResNet18, and a CLIP-based proxy. These models allow</a:t>
+              <a:t>The first level consists of three transparent, white-box-capable proxy models: EfficientNet-B0, ResNet18, and a CLIP-based supervised classifier. All three expose predictions, gradients, and fold-aware checkpoints; CLIP uses a frozen visual encoder and a supervised binary head.</a:t>
             </a:r>
             <a:r>
               <a:rPr lang="it-IT" dirty="0"/>
-              <a:t> (</a:t>
+              <a:t/>
             </a:r>
             <a:r>
               <a:rPr lang="it-IT" dirty="0" err="1"/>
-              <a:t>allaw</a:t>
+              <a:t/>
             </a:r>
             <a:r>
               <a:rPr lang="it-IT" dirty="0"/>
-              <a:t>)</a:t>
+              <a:t/>
             </a:r>
             <a:r>
               <a:rPr dirty="0"/>
-              <a:t> inspection of predictions, gradients, and fold-aware checkpoints.</a:t>
+              <a:t/>
             </a:r>
           </a:p>
           <a:p>
@@ -4223,23 +4223,23 @@
           <a:p>
             <a:r>
               <a:rPr dirty="0"/>
-              <a:t>The threat-model distinction is essential. Model-dependent adversarial attacks are generated directly against EfficientNet-B0. When the same artifacts are evaluated on the other proxies or commercial systems, I measure</a:t>
+              <a:t>Attack knowledge and evaluation role are separate. FGSM, Sigma Zero, and the internal SuperDeepFool adapter use gradients; One Pixel uses scores. EfficientNet-B0 is the designated source model. The other proxies measure cross-model transfer, while commercial systems provide empirical responses to transferred artifacts. Color Shift and the five anti-forensic transformations are model-agnostic.</a:t>
             </a:r>
             <a:r>
               <a:rPr lang="it-IT" dirty="0"/>
-              <a:t> (</a:t>
+              <a:t/>
             </a:r>
             <a:r>
               <a:rPr lang="it-IT" dirty="0" err="1"/>
-              <a:t>misùre</a:t>
+              <a:t/>
             </a:r>
             <a:r>
               <a:rPr lang="it-IT" dirty="0"/>
-              <a:t>)</a:t>
+              <a:t/>
             </a:r>
             <a:r>
               <a:rPr dirty="0"/>
-              <a:t> empirical transfer, not a direct attack. Color Shift and the five anti-forensic transformations are model-agnostic conditions.</a:t>
+              <a:t/>
             </a:r>
           </a:p>
           <a:p>
@@ -4568,7 +4568,7 @@
           <a:p>
             <a:r>
               <a:rPr dirty="0"/>
-              <a:t>This slide shows the difference between direct vulnerability and transferability.</a:t>
+              <a:t>This slide distinguishes source-model evaluation from cross-model transfer.</a:t>
             </a:r>
           </a:p>
           <a:p>
@@ -4595,15 +4595,15 @@
           <a:p>
             <a:r>
               <a:rPr dirty="0"/>
-              <a:t>So these results support two different claims. EfficientNet-B0 shows a severe direct-target vulnerability, while cross-architecture</a:t>
+              <a:t>These results show severe source-model vulnerability for EfficientNet-B0 and much smaller cross-model effects under the tested conditions. Limited transfer does not establish direct robustness of ResNet18 or CLIP because no attacks were optimized against them.</a:t>
             </a:r>
             <a:r>
               <a:rPr lang="it-IT" dirty="0"/>
-              <a:t> (cross-</a:t>
+              <a:t/>
             </a:r>
             <a:r>
               <a:rPr dirty="0"/>
-              <a:t> transfer is much more limited in these frozen conditions.</a:t>
+              <a:t/>
             </a:r>
           </a:p>
           <a:p>
@@ -4642,7 +4642,7 @@
           <a:p>
             <a:r>
               <a:rPr dirty="0"/>
-              <a:t>The commercial black-box results show that transfer is also strongly configuration-dependent.</a:t>
+              <a:t>The commercial black-box results show configuration-dependent responses to the transferred artifacts.</a:t>
             </a:r>
           </a:p>
         </p:txBody>
@@ -4735,7 +4735,7 @@
           <a:p>
             <a:r>
               <a:rPr dirty="0"/>
-              <a:t>This heatmap summarizes empirical transfer on the commercial black-box configurations.</a:t>
+              <a:t>This heatmap summarizes empirical responses to EfficientNet-B0-generated artifacts across the commercial black-box configurations.</a:t>
             </a:r>
           </a:p>
           <a:p>
@@ -4753,15 +4753,15 @@
           <a:p>
             <a:r>
               <a:rPr dirty="0"/>
-              <a:t>The largest observed transfer effects are produced by Sigma Zero on </a:t>
+              <a:t>The largest observed accuracy changes occur for Sigma Zero artifacts on Excire D50 and D80, with drops of 20.2 and 25.8 percentage points.</a:t>
             </a:r>
             <a:r>
               <a:rPr dirty="0" err="1"/>
-              <a:t>Excire</a:t>
+              <a:t/>
             </a:r>
             <a:r>
               <a:rPr dirty="0"/>
-              <a:t> D50 and D80, with accuracy drops of 20.2 and 25.8 percentage points.</a:t>
+              <a:t/>
             </a:r>
           </a:p>
           <a:p>
@@ -4770,7 +4770,7 @@
           <a:p>
             <a:r>
               <a:rPr dirty="0"/>
-              <a:t>These are transfer results from EfficientNet-B0 artifacts. They are not direct attacks against the proprietary models, because their internal models and gradients are not available.</a:t>
+              <a:t>These artifacts were generated on EfficientNet-B0, not optimized against the proprietary models. FGSM, Sigma Zero, and SuperDeepFool were exported as 224 × 224 PNGs, while clean inputs retained native formats and sizes; One Pixel also used PNG serialization. Without a representation-matched clean control, the observed response may combine perturbation, resizing, and serialization effects.</a:t>
             </a:r>
           </a:p>
           <a:p>
@@ -4794,7 +4794,7 @@
           <a:p>
             <a:r>
               <a:rPr dirty="0"/>
-              <a:t>heatmap → heterogeneity → Sigma Zero → D50 −20.2 pp → D80 −25.8 pp → transfer, not direct attack</a:t>
+              <a:t>heatmap → configuration-dependent responses → D50 −20.2 pp / D80 −25.8 pp → representation caveat</a:t>
             </a:r>
           </a:p>
           <a:p>
@@ -14862,7 +14862,7 @@
                 <a:ea typeface="Arial"/>
                 <a:cs typeface="Arial"/>
               </a:rPr>
-              <a:t>one frozen setting per condition</a:t>
+              <a:t>one setting; bounded attack budgets</a:t>
             </a:r>
           </a:p>
         </p:txBody>
@@ -14959,7 +14959,7 @@
                 <a:ea typeface="Arial"/>
                 <a:cs typeface="Arial"/>
               </a:rPr>
-              <a:t>Attack target</a:t>
+              <a:t>Attack source</a:t>
             </a:r>
           </a:p>
         </p:txBody>
@@ -15018,7 +15018,7 @@
                 <a:ea typeface="Arial"/>
                 <a:cs typeface="Arial"/>
               </a:rPr>
-              <a:t>direct attacks only on EfficientNet-B0</a:t>
+              <a:t>source model: EfficientNet-B0</a:t>
             </a:r>
           </a:p>
         </p:txBody>
@@ -15887,7 +15887,7 @@
                 <a:ea typeface="Arial"/>
                 <a:cs typeface="Arial"/>
               </a:rPr>
-              <a:t>Direct attacks, transfer and OOD behavior are distinct from configuration trade-offs.</a:t>
+              <a:t>Source evaluation, transfer, OOD and configuration trade-offs remain distinct.</a:t>
             </a:r>
           </a:p>
         </p:txBody>
@@ -16983,7 +16983,7 @@
                 <a:ea typeface="Arial"/>
                 <a:cs typeface="Arial"/>
               </a:rPr>
-              <a:t>How do direct source-model attacks, cross-architecture transfer and model-agnostic Color Shift differ?</a:t>
+              <a:t>How do proxy responses differ across source-model evaluation, cross-model transfer and model-agnostic Color Shift?</a:t>
             </a:r>
           </a:p>
         </p:txBody>
@@ -17827,7 +17827,7 @@
                 <a:ea typeface="Arial"/>
                 <a:cs typeface="Arial"/>
               </a:rPr>
-              <a:t>FGSM</a:t>
+              <a:t>FGSM · gradient-based</a:t>
             </a:r>
           </a:p>
           <a:p>
@@ -17854,7 +17854,7 @@
                 <a:ea typeface="Arial"/>
                 <a:cs typeface="Arial"/>
               </a:rPr>
-              <a:t>One Pixel</a:t>
+              <a:t>One Pixel · score-based</a:t>
             </a:r>
           </a:p>
           <a:p>
@@ -17881,7 +17881,7 @@
                 <a:ea typeface="Arial"/>
                 <a:cs typeface="Arial"/>
               </a:rPr>
-              <a:t>Sigma Zero</a:t>
+              <a:t>Sigma Zero · gradient-based</a:t>
             </a:r>
           </a:p>
           <a:p>
@@ -17908,7 +17908,7 @@
                 <a:ea typeface="Arial"/>
                 <a:cs typeface="Arial"/>
               </a:rPr>
-              <a:t>SuperDeepFool</a:t>
+              <a:t>SuperDeepFool · gradient-based</a:t>
             </a:r>
           </a:p>
           <a:p>
@@ -18303,7 +18303,7 @@
                 <a:ea typeface="Arial"/>
                 <a:cs typeface="Arial"/>
               </a:rPr>
-              <a:t>Model-dependent attacks: direct on EfficientNet-B0  |  empirical transfer elsewhere</a:t>
+              <a:t>EfficientNet-B0: source evaluation | other proxies: cross-model transfer</a:t>
             </a:r>
           </a:p>
           <a:p>
@@ -18327,7 +18327,7 @@
                 <a:ea typeface="Arial"/>
                 <a:cs typeface="Arial"/>
               </a:rPr>
-              <a:t>Color Shift and anti-forensic transformations: model-agnostic conditions</a:t>
+              <a:t>Commercial: empirical response | Color Shift / anti-forensics: model-agnostic</a:t>
             </a:r>
           </a:p>
         </p:txBody>
@@ -22535,7 +22535,7 @@
                 <a:ea typeface="Arial"/>
                 <a:cs typeface="Arial"/>
               </a:rPr>
-              <a:t>Adversarial settings were frozen before evaluation</a:t>
+              <a:t>Fixed adversarial settings and claim boundaries</a:t>
             </a:r>
           </a:p>
         </p:txBody>
@@ -22977,7 +22977,7 @@
                 <a:ea typeface="Arial"/>
                 <a:cs typeface="Arial"/>
               </a:rPr>
-              <a:t>50 iters · pop. ≈100 · seed 42</a:t>
+              <a:t>50 iters · pop. 100 · seed 42</a:t>
             </a:r>
           </a:p>
         </p:txBody>
@@ -23149,7 +23149,7 @@
                 <a:ea typeface="Arial"/>
                 <a:cs typeface="Arial"/>
               </a:rPr>
-              <a:t>Sigma Zero · 1,000 steps</a:t>
+              <a:t>Sigma Zero · 1,000 reference steps</a:t>
             </a:r>
           </a:p>
           <a:p>
@@ -23236,7 +23236,7 @@
                 <a:ea typeface="Arial"/>
                 <a:cs typeface="Arial"/>
               </a:rPr>
-              <a:t> · SDF(∞,1)</a:t>
+              <a:t> · internal L₂ adapter</a:t>
             </a:r>
           </a:p>
           <a:p>
@@ -23274,7 +23274,7 @@
                 <a:ea typeface="Arial"/>
                 <a:cs typeface="Arial"/>
               </a:rPr>
-              <a:t>20 outer · 50 inner · 1 projection</a:t>
+              <a:t>1 cycle · 50 inner · 1 projection</a:t>
             </a:r>
           </a:p>
         </p:txBody>
@@ -23373,7 +23373,7 @@
                 <a:ea typeface="Arial"/>
                 <a:cs typeface="Arial"/>
               </a:rPr>
-              <a:t>Primary target: EfficientNet-B0 · PNG outputs</a:t>
+              <a:t>Source model: EfficientNet-B0 · PNG outputs</a:t>
             </a:r>
           </a:p>
           <a:p>
@@ -24222,7 +24222,7 @@
                 <a:ea typeface="Arial"/>
                 <a:cs typeface="Arial"/>
               </a:rPr>
-              <a:t>One frozen setting per condition</a:t>
+              <a:t>One fixed setting; no severity-response curve</a:t>
             </a:r>
           </a:p>
         </p:txBody>
@@ -27173,7 +27173,7 @@
                 <a:ea typeface="Arial"/>
                 <a:cs typeface="Arial"/>
               </a:rPr>
-              <a:t>parameter sweeps; adaptive attacks</a:t>
+              <a:t>sweeps; full SDF; matched controls</a:t>
             </a:r>
           </a:p>
         </p:txBody>
@@ -32442,7 +32442,7 @@
                 <a:ea typeface="Arial"/>
                 <a:cs typeface="Arial"/>
               </a:rPr>
-              <a:t>Inspectable predictions · gradients · fold-aware checkpoints</a:t>
+              <a:t>All three white-box-capable · inspectable checkpoints</a:t>
             </a:r>
           </a:p>
         </p:txBody>
@@ -32792,7 +32792,7 @@
                 <a:ea typeface="Arial"/>
                 <a:cs typeface="Arial"/>
               </a:rPr>
-              <a:t>THREAT-MODEL PATHS</a:t>
+              <a:t>EVALUATION PATHS</a:t>
             </a:r>
           </a:p>
         </p:txBody>
@@ -32891,7 +32891,7 @@
                 <a:ea typeface="Arial"/>
                 <a:cs typeface="Arial"/>
               </a:rPr>
-              <a:t>DIRECT TARGET</a:t>
+              <a:t>SOURCE MODEL</a:t>
             </a:r>
           </a:p>
         </p:txBody>
@@ -32950,7 +32950,7 @@
                 <a:ea typeface="Arial"/>
                 <a:cs typeface="Arial"/>
               </a:rPr>
-              <a:t>Model-dependent attacks evaluated on EfficientNet-B0</a:t>
+              <a:t>EfficientNet-B0: source-model evaluation</a:t>
             </a:r>
           </a:p>
         </p:txBody>
@@ -33049,7 +33049,7 @@
                 <a:ea typeface="Arial"/>
                 <a:cs typeface="Arial"/>
               </a:rPr>
-              <a:t>EMPIRICAL TRANSFER</a:t>
+              <a:t>TRANSFER / RESPONSE</a:t>
             </a:r>
           </a:p>
         </p:txBody>
@@ -33108,7 +33108,7 @@
                 <a:ea typeface="Arial"/>
                 <a:cs typeface="Arial"/>
               </a:rPr>
-              <a:t>The same artifacts applied to non-target systems</a:t>
+              <a:t>Proxy transfer · commercial empirical response</a:t>
             </a:r>
           </a:p>
         </p:txBody>
@@ -34807,7 +34807,7 @@
                 <a:ea typeface="Arial"/>
                 <a:cs typeface="Arial"/>
               </a:rPr>
-              <a:t>Direct-target collapse did not transfer uniformly</a:t>
+              <a:t>Source-model collapse did not transfer uniformly</a:t>
             </a:r>
           </a:p>
         </p:txBody>
@@ -35505,7 +35505,7 @@
                 <a:ea typeface="Arial"/>
                 <a:cs typeface="Arial"/>
               </a:rPr>
-              <a:t>Sigma Zero · direct</a:t>
+              <a:t>Sigma Zero · source</a:t>
             </a:r>
           </a:p>
         </p:txBody>
@@ -36689,7 +36689,7 @@
                 <a:ea typeface="Arial"/>
                 <a:cs typeface="Arial"/>
               </a:rPr>
-              <a:t>Black-box transfer was configuration-dependent</a:t>
+              <a:t>Black-box responses depended on configuration</a:t>
             </a:r>
           </a:p>
         </p:txBody>
@@ -36957,7 +36957,7 @@
                 <a:ea typeface="Arial"/>
                 <a:cs typeface="Arial"/>
               </a:rPr>
-              <a:t>Largest transfer effects: Sigma Zero · Excire D50 −20.2 pp · D80 −25.8 pp</a:t>
+              <a:t>Largest observed changes: Sigma Zero · Excire D50 −20.2 pp · D80 −25.8 pp</a:t>
             </a:r>
           </a:p>
         </p:txBody>
@@ -37016,7 +37016,7 @@
                 <a:ea typeface="Arial"/>
                 <a:cs typeface="Arial"/>
               </a:rPr>
-              <a:t>Transfer from EfficientNet-B0 artifacts—not direct attacks · Source: FAIRLab manuscript</a:t>
+              <a:t>EfficientNet-B0 artifacts · no matched clean representation control</a:t>
             </a:r>
           </a:p>
         </p:txBody>

</xml_diff>

<commit_message>
Expose GKC threat model in defense materials
</commit_message>
<xml_diff>
--- a/Molinario_Thesis_Defense_2026.pptx
+++ b/Molinario_Thesis_Defense_2026.pptx
@@ -2534,7 +2534,7 @@
           <a:lstStyle/>
           <a:p>
             <a:r>
-              <a:t>BACKUP B2 — PERTURBATION SUITE AND THREAT PATHS</a:t>
+              <a:t>BACKUP B2 — GKC THREAT MODEL AND PERTURBATION SUITE</a:t>
             </a:r>
           </a:p>
           <a:p>
@@ -2547,7 +2547,7 @@
           </a:p>
           <a:p>
             <a:r>
-              <a:t>The commission asks: “Which attacks and transformations did you evaluate?” or “Which ones are direct attacks?”</a:t>
+              <a:t>The commission asks: “What is your threat model?” or “Which attacks and transformations did you evaluate?”</a:t>
             </a:r>
           </a:p>
           <a:p>
@@ -2568,7 +2568,7 @@
           </a:p>
           <a:p>
             <a:r>
-              <a:t>Attack knowledge is gradient-based for FGSM, Sigma Zero, and the internal SuperDeepFool adapter, and score-based for One Pixel. All three proxies are inspectable and white-box-capable, but only EfficientNet-B0 was used for model-dependent generation. ResNet18 and CLIP measure cross-model transfer; commercial systems provide empirical responses. Color Shift and the anti-forensic transformations are model-agnostic.</a:t>
+              <a:t>The adversarial threat model uses Goal, Knowledge, and Capability. Goal: the model-dependent attacks seek untargeted misclassification. Knowledge: FGSM, Sigma Zero, and the internal SuperDeepFool adapter use gradients, while One Pixel uses scores. Capability: the attacker modifies image inputs at inference time within the constraints of each condition, without altering model training. All three proxies are inspectable and white-box-capable, but only EfficientNet-B0 was used for model-dependent generation. ResNet18 and CLIP measure cross-model transfer; commercial systems provide empirical responses. Color Shift and the anti-forensic transformations are model-agnostic, with anti-forensics evaluated separately from adversarial attacks.</a:t>
             </a:r>
           </a:p>
           <a:p>
@@ -2581,7 +2581,7 @@
           </a:p>
           <a:p>
             <a:r>
-              <a:t>gradient-based / score-based / model-agnostic → EfficientNet source → proxy transfer → commercial response</a:t>
+              <a:t>Goal: untargeted errors → Knowledge: gradient / score / model-agnostic → Capability: constrained evasion → source / transfer / commercial response</a:t>
             </a:r>
           </a:p>
         </p:txBody>
@@ -4223,7 +4223,7 @@
           <a:p>
             <a:r>
               <a:rPr dirty="0"/>
-              <a:t>Attack knowledge and evaluation role are separate. FGSM, Sigma Zero, and the internal SuperDeepFool adapter use gradients; One Pixel uses scores. EfficientNet-B0 is the designated source model. The other proxies measure cross-model transfer, while commercial systems provide empirical responses to transferred artifacts. Color Shift and the five anti-forensic transformations are model-agnostic.</a:t>
+              <a:t>The threat model specifies Goal, Knowledge, and Capability. The goal of model-dependent attacks is untargeted misclassification. Knowledge is gradient-based for FGSM, Sigma Zero, and the internal SuperDeepFool adapter, and score-based for One Pixel. Capability is constrained image manipulation at inference time. EfficientNet-B0 is the source model. Other proxies measure transfer, and commercial systems provide empirical responses to transferred artifacts. Color Shift and anti-forensic transformations are model-agnostic, with anti-forensics evaluated separately from adversarial attacks.</a:t>
             </a:r>
             <a:r>
               <a:rPr lang="it-IT" dirty="0"/>
@@ -4254,7 +4254,7 @@
           <a:p>
             <a:r>
               <a:rPr dirty="0"/>
-              <a:t>transparent proxies → black-box tools → direct target = EfficientNet-B0 → transfer elsewhere → model-agnostic conditions</a:t>
+              <a:t>GKC: untargeted errors → gradient / score access → constrained test-time changes → source / transfer → model-agnostic conditions</a:t>
             </a:r>
           </a:p>
           <a:p>
@@ -17529,7 +17529,7 @@
                 <a:ea typeface="Arial"/>
                 <a:cs typeface="Arial"/>
               </a:rPr>
-              <a:t>Perturbation suite and threat paths</a:t>
+              <a:t>GKC threat model and perturbation suite</a:t>
             </a:r>
           </a:p>
         </p:txBody>
@@ -18303,7 +18303,7 @@
                 <a:ea typeface="Arial"/>
                 <a:cs typeface="Arial"/>
               </a:rPr>
-              <a:t>EfficientNet-B0: source evaluation | other proxies: cross-model transfer</a:t>
+              <a:t>Goal: untargeted model-dependent attacks. Knowledge: gradients or scores.</a:t>
             </a:r>
           </a:p>
           <a:p>
@@ -18327,7 +18327,7 @@
                 <a:ea typeface="Arial"/>
                 <a:cs typeface="Arial"/>
               </a:rPr>
-              <a:t>Commercial: empirical response | Color Shift / anti-forensics: model-agnostic</a:t>
+              <a:t>Capability: constrained image changes at inference time (evasion).</a:t>
             </a:r>
           </a:p>
         </p:txBody>

</xml_diff>